<commit_message>
docs(demo): rebuild narrated cut and deck for the Meterless integration
</commit_message>
<xml_diff>
--- a/docs/demo/driftwatch-deck.pptx
+++ b/docs/demo/driftwatch-deck.pptx
@@ -9,6 +9,7 @@
     <p:sldId id="257" r:id="rId9"/>
     <p:sldId id="258" r:id="rId10"/>
     <p:sldId id="259" r:id="rId11"/>
+    <p:sldId id="266" r:id="rId18"/>
     <p:sldId id="260" r:id="rId12"/>
     <p:sldId id="261" r:id="rId13"/>
     <p:sldId id="262" r:id="rId14"/>
@@ -4274,6 +4275,129 @@
                   <a:srgbClr val="E8ECF4"/>
                 </a:solidFill>
               </a:rPr>
+              <a:t>How it was built — attributed honestly</a:t>
+            </a:r>
+          </a:p>
+        </p:txBody>
+      </p:sp>
+      <p:sp>
+        <p:nvSpPr>
+          <p:cNvPr id="3" name="Content Placeholder 2"/>
+          <p:cNvSpPr>
+            <a:spLocks noGrp="1"/>
+          </p:cNvSpPr>
+          <p:nvPr>
+            <p:ph idx="1"/>
+          </p:nvPr>
+        </p:nvSpPr>
+        <p:spPr/>
+        <p:txBody>
+          <a:bodyPr/>
+          <a:lstStyle/>
+          <a:p>
+            <a:pPr/>
+            <a:r>
+              <a:rPr sz="2000">
+                <a:solidFill>
+                  <a:srgbClr val="DDE3EC"/>
+                </a:solidFill>
+              </a:rPr>
+              <a:t>Cursor agent CLI drove Tasks 1–2 (session logs retained); free-tier quota exhausted mid-window — blocker posted to HackOS, the announced rule change captured</a:t>
+            </a:r>
+          </a:p>
+          <a:p>
+            <a:pPr/>
+            <a:r>
+              <a:rPr sz="2000">
+                <a:solidFill>
+                  <a:srgbClr val="DDE3EC"/>
+                </a:solidFill>
+              </a:rPr>
+              <a:t>Hermes agent drove Tasks 3–6 with TDD throughout; per-task attribution lives in the committed build log</a:t>
+            </a:r>
+          </a:p>
+          <a:p>
+            <a:pPr/>
+            <a:r>
+              <a:rPr sz="2000">
+                <a:solidFill>
+                  <a:srgbClr val="94A3B8"/>
+                </a:solidFill>
+              </a:rPr>
+              <a:t>Every mutating step on the live Zetaris instance went through a dry-run approval package first — recorded in decisions.md</a:t>
+            </a:r>
+          </a:p>
+          <a:p>
+            <a:pPr/>
+            <a:r>
+              <a:rPr sz="2000">
+                <a:solidFill>
+                  <a:srgbClr val="DDE3EC"/>
+                </a:solidFill>
+              </a:rPr>
+              <a:t>NVIDIA: model path is provider-agnostic (OpenAI-compatible, Nemotron-capable endpoints unconfirmed) — stated as-is</a:t>
+            </a:r>
+          </a:p>
+          <a:p>
+            <a:pPr/>
+            <a:r>
+              <a:rPr sz="2000">
+                <a:solidFill>
+                  <a:srgbClr val="DDE3EC"/>
+                </a:solidFill>
+              </a:rPr>
+              <a:t>Meterless: World Model engine implemented in app/world_model/ and consumed by Scout and Skeptic, with generated offline acceptance; Nightshift provider implemented and contract-tested, never served a live request (vendor Mac build fails Gatekeeper) — stated as-is</a:t>
+            </a:r>
+          </a:p>
+        </p:txBody>
+      </p:sp>
+    </p:spTree>
+  </p:cSld>
+  <p:clrMapOvr>
+    <a:masterClrMapping/>
+  </p:clrMapOvr>
+</p:sld>
+</file>
+
+<file path=ppt/slides/slide11.xml><?xml version="1.0" encoding="utf-8"?>
+<p:sld xmlns:a="http://schemas.openxmlformats.org/drawingml/2006/main" xmlns:p="http://schemas.openxmlformats.org/presentationml/2006/main" xmlns:r="http://schemas.openxmlformats.org/officeDocument/2006/relationships">
+  <p:cSld>
+    <p:bg>
+      <p:bgPr>
+        <a:solidFill>
+          <a:srgbClr val="151A23"/>
+        </a:solidFill>
+        <a:effectLst/>
+      </p:bgPr>
+    </p:bg>
+    <p:spTree>
+      <p:nvGrpSpPr>
+        <p:cNvPr id="1" name=""/>
+        <p:cNvGrpSpPr/>
+        <p:nvPr/>
+      </p:nvGrpSpPr>
+      <p:grpSpPr/>
+      <p:sp>
+        <p:nvSpPr>
+          <p:cNvPr id="2" name="Title 1"/>
+          <p:cNvSpPr>
+            <a:spLocks noGrp="1"/>
+          </p:cNvSpPr>
+          <p:nvPr>
+            <p:ph type="title"/>
+          </p:nvPr>
+        </p:nvSpPr>
+        <p:spPr/>
+        <p:txBody>
+          <a:bodyPr/>
+          <a:lstStyle/>
+          <a:p>
+            <a:r>
+              <a:rPr>
+                <a:solidFill>
+                  <a:srgbClr val="E8ECF4"/>
+                </a:solidFill>
+              </a:rPr>
               <a:t>Run it yourself — no keys required</a:t>
             </a:r>
           </a:p>
@@ -4585,7 +4709,7 @@
                   <a:srgbClr val="94A3B8"/>
                 </a:solidFill>
               </a:rPr>
-              <a:t>Hand-rolled, no orchestration framework — 259 tests instead of a dependency tree</a:t>
+              <a:t>Hand-rolled, no orchestration framework — 456 tests instead of a dependency tree</a:t>
             </a:r>
           </a:p>
         </p:txBody>
@@ -4724,6 +4848,121 @@
 <file path=ppt/slides/slide5.xml><?xml version="1.0" encoding="utf-8"?>
 <p:sld xmlns:a="http://schemas.openxmlformats.org/drawingml/2006/main" xmlns:p="http://schemas.openxmlformats.org/presentationml/2006/main" xmlns:r="http://schemas.openxmlformats.org/officeDocument/2006/relationships">
   <p:cSld>
+    <p:spTree>
+      <p:nvGrpSpPr>
+        <p:cNvPr id="1" name=""/>
+        <p:cNvGrpSpPr/>
+        <p:nvPr/>
+      </p:nvGrpSpPr>
+      <p:grpSpPr/>
+      <p:sp>
+        <p:nvSpPr>
+          <p:cNvPr id="2" name="Title 1"/>
+          <p:cNvSpPr>
+            <a:spLocks noGrp="1"/>
+          </p:cNvSpPr>
+          <p:nvPr>
+            <p:ph type="title"/>
+          </p:nvPr>
+        </p:nvSpPr>
+        <p:spPr/>
+        <p:txBody>
+          <a:bodyPr/>
+          <a:lstStyle/>
+          <a:p>
+            <a:r>
+              <a:rPr>
+                <a:solidFill>
+                  <a:srgbClr val="E8ECF4"/>
+                </a:solidFill>
+              </a:rPr>
+              <a:t>Meterless: the engine is load-bearing, the provider is honest</a:t>
+            </a:r>
+          </a:p>
+        </p:txBody>
+      </p:sp>
+      <p:sp>
+        <p:nvSpPr>
+          <p:cNvPr id="3" name="Content Placeholder 2"/>
+          <p:cNvSpPr>
+            <a:spLocks noGrp="1"/>
+          </p:cNvSpPr>
+          <p:nvPr>
+            <p:ph idx="1"/>
+          </p:nvPr>
+        </p:nvSpPr>
+        <p:spPr/>
+        <p:txBody>
+          <a:bodyPr/>
+          <a:lstStyle/>
+          <a:p>
+            <a:pPr/>
+            <a:r>
+              <a:rPr sz="1700">
+                <a:solidFill>
+                  <a:srgbClr val="DDE3EC"/>
+                </a:solidFill>
+              </a:rPr>
+              <a:t>World Model engine in app/world_model/ — immutable observation store, validated ingestion, context pinned to one exact run</a:t>
+            </a:r>
+          </a:p>
+          <a:p>
+            <a:pPr/>
+            <a:r>
+              <a:rPr sz="1700">
+                <a:solidFill>
+                  <a:srgbClr val="DDE3EC"/>
+                </a:solidFill>
+              </a:rPr>
+              <a:t>Scout and Skeptic both read through it; every finding carries the provenance of the observation behind it</a:t>
+            </a:r>
+          </a:p>
+          <a:p>
+            <a:pPr/>
+            <a:r>
+              <a:rPr sz="1700">
+                <a:solidFill>
+                  <a:srgbClr val="7DD3FC"/>
+                </a:solidFill>
+              </a:rPr>
+              <a:t>Acceptance is generated, not written: verify_world_model.py rebuilds the proof offline, with no credentials</a:t>
+            </a:r>
+          </a:p>
+          <a:p>
+            <a:pPr/>
+            <a:r>
+              <a:rPr sz="1700">
+                <a:solidFill>
+                  <a:srgbClr val="DDE3EC"/>
+                </a:solidFill>
+              </a:rPr>
+              <a:t>Nightshift is wired to the documented contract — bearer auth, /v1/models discovery, 60s budget, redirects refused — and contract-tested</a:t>
+            </a:r>
+          </a:p>
+          <a:p>
+            <a:pPr/>
+            <a:r>
+              <a:rPr sz="1700" i="1">
+                <a:solidFill>
+                  <a:srgbClr val="94A3B8"/>
+                </a:solidFill>
+              </a:rPr>
+              <a:t>Not yet live: the vendor's Mac build fails Gatekeeper and we did not bypass it, so the report says not_used</a:t>
+            </a:r>
+          </a:p>
+        </p:txBody>
+      </p:sp>
+    </p:spTree>
+  </p:cSld>
+  <p:clrMapOvr>
+    <a:masterClrMapping/>
+  </p:clrMapOvr>
+</p:sld>
+</file>
+
+<file path=ppt/slides/slide6.xml><?xml version="1.0" encoding="utf-8"?>
+<p:sld xmlns:a="http://schemas.openxmlformats.org/drawingml/2006/main" xmlns:p="http://schemas.openxmlformats.org/presentationml/2006/main" xmlns:r="http://schemas.openxmlformats.org/officeDocument/2006/relationships">
+  <p:cSld>
     <p:bg>
       <p:bgPr>
         <a:solidFill>
@@ -4773,7 +5012,7 @@
 </p:sld>
 </file>
 
-<file path=ppt/slides/slide6.xml><?xml version="1.0" encoding="utf-8"?>
+<file path=ppt/slides/slide7.xml><?xml version="1.0" encoding="utf-8"?>
 <p:sld xmlns:a="http://schemas.openxmlformats.org/drawingml/2006/main" xmlns:p="http://schemas.openxmlformats.org/presentationml/2006/main" xmlns:r="http://schemas.openxmlformats.org/officeDocument/2006/relationships">
   <p:cSld>
     <p:spTree>
@@ -5182,118 +5421,6 @@
 </p:sld>
 </file>
 
-<file path=ppt/slides/slide7.xml><?xml version="1.0" encoding="utf-8"?>
-<p:sld xmlns:a="http://schemas.openxmlformats.org/drawingml/2006/main" xmlns:p="http://schemas.openxmlformats.org/presentationml/2006/main" xmlns:r="http://schemas.openxmlformats.org/officeDocument/2006/relationships">
-  <p:cSld>
-    <p:bg>
-      <p:bgPr>
-        <a:solidFill>
-          <a:srgbClr val="151A23"/>
-        </a:solidFill>
-        <a:effectLst/>
-      </p:bgPr>
-    </p:bg>
-    <p:spTree>
-      <p:nvGrpSpPr>
-        <p:cNvPr id="1" name=""/>
-        <p:cNvGrpSpPr/>
-        <p:nvPr/>
-      </p:nvGrpSpPr>
-      <p:grpSpPr/>
-      <p:sp>
-        <p:nvSpPr>
-          <p:cNvPr id="2" name="Title 1"/>
-          <p:cNvSpPr>
-            <a:spLocks noGrp="1"/>
-          </p:cNvSpPr>
-          <p:nvPr>
-            <p:ph type="title"/>
-          </p:nvPr>
-        </p:nvSpPr>
-        <p:spPr/>
-        <p:txBody>
-          <a:bodyPr/>
-          <a:lstStyle/>
-          <a:p>
-            <a:r>
-              <a:rPr>
-                <a:solidFill>
-                  <a:srgbClr val="E8ECF4"/>
-                </a:solidFill>
-              </a:rPr>
-              <a:t>Our guard caught a supplier bug in production</a:t>
-            </a:r>
-          </a:p>
-        </p:txBody>
-      </p:sp>
-      <p:sp>
-        <p:nvSpPr>
-          <p:cNvPr id="3" name="Content Placeholder 2"/>
-          <p:cNvSpPr>
-            <a:spLocks noGrp="1"/>
-          </p:cNvSpPr>
-          <p:nvPr>
-            <p:ph idx="1"/>
-          </p:nvPr>
-        </p:nvSpPr>
-        <p:spPr/>
-        <p:txBody>
-          <a:bodyPr/>
-          <a:lstStyle/>
-          <a:p>
-            <a:pPr/>
-            <a:r>
-              <a:rPr sz="2000">
-                <a:solidFill>
-                  <a:srgbClr val="DDE3EC"/>
-                </a:solidFill>
-              </a:rPr>
-              <a:t>The live engine’s CSV parser silently truncates cells at embedded quotes — row counts and headers looked fine</a:t>
-            </a:r>
-          </a:p>
-          <a:p>
-            <a:pPr/>
-            <a:r>
-              <a:rPr sz="2000" b="1">
-                <a:solidFill>
-                  <a:srgbClr val="7DD3FC"/>
-                </a:solidFill>
-              </a:rPr>
-              <a:t>Our content-digest check rejected every fetch; the run degraded to fixture data honestly — no corrupted rule ever reached an agent</a:t>
-            </a:r>
-          </a:p>
-          <a:p>
-            <a:pPr/>
-            <a:r>
-              <a:rPr sz="2000">
-                <a:solidFill>
-                  <a:srgbClr val="DDE3EC"/>
-                </a:solidFill>
-              </a:rPr>
-              <a:t>Response: quote-safe re-export (digests unchanged), new immutable snapshots, v1 revoked and dropped, supplier defect report written up</a:t>
-            </a:r>
-          </a:p>
-          <a:p>
-            <a:pPr/>
-            <a:r>
-              <a:rPr sz="2000" i="1">
-                <a:solidFill>
-                  <a:srgbClr val="FBBF24"/>
-                </a:solidFill>
-              </a:rPr>
-              <a:t>“A connector’s happy path is not its contract — validate the payload after the wire, not just the status code.”</a:t>
-            </a:r>
-          </a:p>
-        </p:txBody>
-      </p:sp>
-    </p:spTree>
-  </p:cSld>
-  <p:clrMapOvr>
-    <a:masterClrMapping/>
-  </p:clrMapOvr>
-</p:sld>
-</file>
-
 <file path=ppt/slides/slide8.xml><?xml version="1.0" encoding="utf-8"?>
 <p:sld xmlns:a="http://schemas.openxmlformats.org/drawingml/2006/main" xmlns:p="http://schemas.openxmlformats.org/presentationml/2006/main" xmlns:r="http://schemas.openxmlformats.org/officeDocument/2006/relationships">
   <p:cSld>
@@ -5333,7 +5460,7 @@
                   <a:srgbClr val="E8ECF4"/>
                 </a:solidFill>
               </a:rPr>
-              <a:t>Measured, not promised</a:t>
+              <a:t>Our guard caught a supplier bug in production</a:t>
             </a:r>
           </a:p>
         </p:txBody>
@@ -5355,12 +5482,23 @@
           <a:p>
             <a:pPr/>
             <a:r>
+              <a:rPr sz="2000">
+                <a:solidFill>
+                  <a:srgbClr val="DDE3EC"/>
+                </a:solidFill>
+              </a:rPr>
+              <a:t>The live engine’s CSV parser silently truncates cells at embedded quotes — row counts and headers looked fine</a:t>
+            </a:r>
+          </a:p>
+          <a:p>
+            <a:pPr/>
+            <a:r>
               <a:rPr sz="2000" b="1">
                 <a:solidFill>
                   <a:srgbClr val="7DD3FC"/>
                 </a:solidFill>
               </a:rPr>
-              <a:t>3 curated scenarios: precision 1.0 · recall 1.0 · verdict accuracy 1.0 · deterministic</a:t>
+              <a:t>Our content-digest check rejected every fetch; the run degraded to fixture data honestly — no corrupted rule ever reached an agent</a:t>
             </a:r>
           </a:p>
           <a:p>
@@ -5371,40 +5509,18 @@
                   <a:srgbClr val="DDE3EC"/>
                 </a:solidFill>
               </a:rPr>
-              <a:t>10 held-out generated tenancies: same scores — and the generator exposed two real defects the curated set missed; both fixed, both now guarded by tests</a:t>
+              <a:t>Response: quote-safe re-export (digests unchanged), new immutable snapshots, v1 revoked and dropped, supplier defect report written up</a:t>
             </a:r>
           </a:p>
           <a:p>
             <a:pPr/>
             <a:r>
-              <a:rPr sz="2000">
-                <a:solidFill>
-                  <a:srgbClr val="DDE3EC"/>
+              <a:rPr sz="2000" i="1">
+                <a:solidFill>
+                  <a:srgbClr val="FBBF24"/>
                 </a:solidFill>
               </a:rPr>
-              <a:t>259 tests; sample-mode isolation enforced by blocking sockets and subprocess creation with sponsor vars present and absent</a:t>
-            </a:r>
-          </a:p>
-          <a:p>
-            <a:pPr/>
-            <a:r>
-              <a:rPr sz="2000">
-                <a:solidFill>
-                  <a:srgbClr val="DDE3EC"/>
-                </a:solidFill>
-              </a:rPr>
-              <a:t>Packaging verified from fresh clone, in containers on x86 and arm64, via POST /run — JSON in, JSON out, no UI needed</a:t>
-            </a:r>
-          </a:p>
-          <a:p>
-            <a:pPr/>
-            <a:r>
-              <a:rPr sz="2000">
-                <a:solidFill>
-                  <a:srgbClr val="94A3B8"/>
-                </a:solidFill>
-              </a:rPr>
-              <a:t>Every external call has a timeout; every loop has a cap; a run finishes in minutes</a:t>
+              <a:t>“A connector’s happy path is not its contract — validate the payload after the wire, not just the status code.”</a:t>
             </a:r>
           </a:p>
         </p:txBody>
@@ -5456,7 +5572,7 @@
                   <a:srgbClr val="E8ECF4"/>
                 </a:solidFill>
               </a:rPr>
-              <a:t>How it was built — attributed honestly</a:t>
+              <a:t>Measured, not promised</a:t>
             </a:r>
           </a:p>
         </p:txBody>
@@ -5478,12 +5594,23 @@
           <a:p>
             <a:pPr/>
             <a:r>
+              <a:rPr sz="2000" b="1">
+                <a:solidFill>
+                  <a:srgbClr val="7DD3FC"/>
+                </a:solidFill>
+              </a:rPr>
+              <a:t>3 curated scenarios: precision 1.0 · recall 1.0 · verdict accuracy 1.0 · deterministic</a:t>
+            </a:r>
+          </a:p>
+          <a:p>
+            <a:pPr/>
+            <a:r>
               <a:rPr sz="2000">
                 <a:solidFill>
                   <a:srgbClr val="DDE3EC"/>
                 </a:solidFill>
               </a:rPr>
-              <a:t>Cursor agent CLI drove Tasks 1–2 (session logs retained); free-tier quota exhausted mid-window — blocker posted to HackOS, the announced rule change captured</a:t>
+              <a:t>10 held-out generated tenancies: same scores — and the generator exposed two real defects the curated set missed; both fixed, both now guarded by tests</a:t>
             </a:r>
           </a:p>
           <a:p>
@@ -5494,7 +5621,7 @@
                   <a:srgbClr val="DDE3EC"/>
                 </a:solidFill>
               </a:rPr>
-              <a:t>Hermes agent drove Tasks 3–6 with TDD throughout; per-task attribution lives in the committed build log</a:t>
+              <a:t>456 tests; sample-mode isolation enforced by blocking sockets and subprocess creation with sponsor vars present and absent</a:t>
             </a:r>
           </a:p>
           <a:p>
@@ -5502,32 +5629,21 @@
             <a:r>
               <a:rPr sz="2000">
                 <a:solidFill>
+                  <a:srgbClr val="DDE3EC"/>
+                </a:solidFill>
+              </a:rPr>
+              <a:t>Packaging verified from fresh clone, in containers on x86 and arm64, via POST /run — JSON in, JSON out, no UI needed</a:t>
+            </a:r>
+          </a:p>
+          <a:p>
+            <a:pPr/>
+            <a:r>
+              <a:rPr sz="2000">
+                <a:solidFill>
                   <a:srgbClr val="94A3B8"/>
                 </a:solidFill>
               </a:rPr>
-              <a:t>Every mutating step on the live Zetaris instance went through a dry-run approval package first — recorded in decisions.md</a:t>
-            </a:r>
-          </a:p>
-          <a:p>
-            <a:pPr/>
-            <a:r>
-              <a:rPr sz="2000">
-                <a:solidFill>
-                  <a:srgbClr val="DDE3EC"/>
-                </a:solidFill>
-              </a:rPr>
-              <a:t>NVIDIA: model path is provider-agnostic (OpenAI-compatible, Nemotron-capable endpoints unconfirmed) — stated as-is</a:t>
-            </a:r>
-          </a:p>
-          <a:p>
-            <a:pPr/>
-            <a:r>
-              <a:rPr sz="2000">
-                <a:solidFill>
-                  <a:srgbClr val="DDE3EC"/>
-                </a:solidFill>
-              </a:rPr>
-              <a:t>Meterless: honestly unmounted; the bounded loop implements the same discipline the engine specs describe</a:t>
+              <a:t>Every external call has a timeout; every loop has a cap; a run finishes in minutes</a:t>
             </a:r>
           </a:p>
         </p:txBody>

</xml_diff>

<commit_message>
docs(deck): restore the Zetaris acceptance screenshot on its own evidence slide
</commit_message>
<xml_diff>
--- a/docs/demo/driftwatch-deck.pptx
+++ b/docs/demo/driftwatch-deck.pptx
@@ -16,6 +16,7 @@
     <p:sldId id="264" r:id="rId16"/>
     <p:sldId id="265" r:id="rId17"/>
     <p:sldId id="266" r:id="rId18"/>
+    <p:sldId id="267" r:id="rId19"/>
   </p:sldIdLst>
   <p:sldSz cx="12191695" cy="6858000" type="screen4x3"/>
   <p:notesSz cx="6858000" cy="9144000"/>
@@ -582,7 +583,7 @@
           <a:lstStyle/>
           <a:p>
             <a:r>
-              <a:t>Attribution is a rule, not a courtesy. This slide lists what each tool actually did.</a:t>
+              <a:t>Numbers on a slide are cheap. These are the ones the repo can reproduce, including the two defects the held-out generator found.</a:t>
             </a:r>
           </a:p>
         </p:txBody>
@@ -652,6 +653,76 @@
           <a:lstStyle/>
           <a:p>
             <a:r>
+              <a:t>Attribution is a rule, not a courtesy. This slide lists what each tool actually did.</a:t>
+            </a:r>
+          </a:p>
+        </p:txBody>
+      </p:sp>
+      <p:sp>
+        <p:nvSpPr>
+          <p:cNvPr id="4" name="Slide Number Placeholder 3"/>
+          <p:cNvSpPr>
+            <a:spLocks noGrp="1"/>
+          </p:cNvSpPr>
+          <p:nvPr>
+            <p:ph type="sldNum" idx="5" sz="quarter"/>
+          </p:nvPr>
+        </p:nvSpPr>
+        <p:spPr/>
+      </p:sp>
+    </p:spTree>
+  </p:cSld>
+  <p:clrMapOvr>
+    <a:masterClrMapping/>
+  </p:clrMapOvr>
+</p:notes>
+</file>
+
+<file path=ppt/notesSlides/notesSlide12.xml><?xml version="1.0" encoding="utf-8"?>
+<p:notes xmlns:a="http://schemas.openxmlformats.org/drawingml/2006/main" xmlns:p="http://schemas.openxmlformats.org/presentationml/2006/main" xmlns:r="http://schemas.openxmlformats.org/officeDocument/2006/relationships">
+  <p:cSld>
+    <p:spTree>
+      <p:nvGrpSpPr>
+        <p:cNvPr id="1" name=""/>
+        <p:cNvGrpSpPr/>
+        <p:nvPr/>
+      </p:nvGrpSpPr>
+      <p:grpSpPr>
+        <a:xfrm>
+          <a:off x="0" y="0"/>
+          <a:ext cx="0" cy="0"/>
+          <a:chOff x="0" y="0"/>
+          <a:chExt cx="0" cy="0"/>
+        </a:xfrm>
+      </p:grpSpPr>
+      <p:sp>
+        <p:nvSpPr>
+          <p:cNvPr id="2" name="Slide Image Placeholder 1"/>
+          <p:cNvSpPr>
+            <a:spLocks noGrp="1"/>
+          </p:cNvSpPr>
+          <p:nvPr>
+            <p:ph type="sldImg" idx="2"/>
+          </p:nvPr>
+        </p:nvSpPr>
+        <p:spPr/>
+      </p:sp>
+      <p:sp>
+        <p:nvSpPr>
+          <p:cNvPr id="3" name="Notes Placeholder 2"/>
+          <p:cNvSpPr>
+            <a:spLocks noGrp="1"/>
+          </p:cNvSpPr>
+          <p:nvPr>
+            <p:ph type="body" idx="3" sz="quarter"/>
+          </p:nvPr>
+        </p:nvSpPr>
+        <p:spPr/>
+        <p:txBody>
+          <a:bodyPr/>
+          <a:lstStyle/>
+          <a:p>
+            <a:r>
               <a:t>A judge can clone and run this in two commands. Nothing installs at run time.</a:t>
             </a:r>
           </a:p>
@@ -1142,7 +1213,7 @@
           <a:lstStyle/>
           <a:p>
             <a:r>
-              <a:t>This is the credibility slide: the guard that was built to catch our own bad data caught the vendor's.</a:t>
+              <a:t>The screenshot is the actual terminal output of the Zetaris acceptance run that the evidence directory records. It is here so a judge can read the diff without leaving the deck.</a:t>
             </a:r>
           </a:p>
         </p:txBody>
@@ -1212,7 +1283,7 @@
           <a:lstStyle/>
           <a:p>
             <a:r>
-              <a:t>Numbers on a slide are cheap. These are the ones the repo can reproduce, including the two defects the held-out generator found.</a:t>
+              <a:t>This is the credibility slide: the guard that was built to catch our own bad data caught the vendor's.</a:t>
             </a:r>
           </a:p>
         </p:txBody>
@@ -4572,7 +4643,7 @@
                 </a:solidFill>
                 <a:latin typeface="Arial"/>
               </a:rPr>
-              <a:t>DISCLOSURE</a:t>
+              <a:t>MEASUREMENT</a:t>
             </a:r>
           </a:p>
         </p:txBody>
@@ -4611,7 +4682,7 @@
                 </a:solidFill>
                 <a:latin typeface="Arial"/>
               </a:rPr>
-              <a:t>How it was built — attributed honestly</a:t>
+              <a:t>Measured, not promised</a:t>
             </a:r>
           </a:p>
         </p:txBody>
@@ -4731,14 +4802,197 @@
       </p:sp>
       <p:sp>
         <p:nvSpPr>
-          <p:cNvPr id="7" name="TextBox 6"/>
+          <p:cNvPr id="7" name="Rounded Rectangle 6"/>
+          <p:cNvSpPr/>
+          <p:nvPr/>
+        </p:nvSpPr>
+        <p:spPr>
+          <a:xfrm>
+            <a:off x="914400" y="1920240"/>
+            <a:ext cx="3246120" cy="1874519"/>
+          </a:xfrm>
+          <a:prstGeom prst="roundRect">
+            <a:avLst>
+              <a:gd name="adj" fmla="val 6000"/>
+            </a:avLst>
+          </a:prstGeom>
+          <a:solidFill>
+            <a:srgbClr val="1E222C"/>
+          </a:solidFill>
+          <a:ln>
+            <a:noFill/>
+          </a:ln>
+          <a:effectLst/>
+        </p:spPr>
+        <p:txBody>
+          <a:bodyPr rtlCol="0" anchor="t" wrap="square" lIns="164592" rIns="164592" tIns="91440" bIns="91440"/>
+          <a:lstStyle/>
+          <a:p>
+            <a:pPr algn="l">
+              <a:lnSpc>
+                <a:spcPct val="100000"/>
+              </a:lnSpc>
+            </a:pPr>
+            <a:r>
+              <a:rPr sz="3400" b="1">
+                <a:solidFill>
+                  <a:srgbClr val="4FD1C5"/>
+                </a:solidFill>
+                <a:latin typeface="Arial"/>
+              </a:rPr>
+              <a:t>3 / 3</a:t>
+            </a:r>
+          </a:p>
+          <a:p>
+            <a:pPr algn="l">
+              <a:lnSpc>
+                <a:spcPct val="120000"/>
+              </a:lnSpc>
+            </a:pPr>
+            <a:r>
+              <a:rPr sz="1150" b="0">
+                <a:solidFill>
+                  <a:srgbClr val="9BA6B8"/>
+                </a:solidFill>
+                <a:latin typeface="Arial"/>
+              </a:rPr>
+              <a:t>Curated scenarios — precision, recall and verdict accuracy all 1.0, deterministic</a:t>
+            </a:r>
+          </a:p>
+        </p:txBody>
+      </p:sp>
+      <p:sp>
+        <p:nvSpPr>
+          <p:cNvPr id="8" name="Rounded Rectangle 7"/>
+          <p:cNvSpPr/>
+          <p:nvPr/>
+        </p:nvSpPr>
+        <p:spPr>
+          <a:xfrm>
+            <a:off x="4471416" y="1920240"/>
+            <a:ext cx="3246120" cy="1874519"/>
+          </a:xfrm>
+          <a:prstGeom prst="roundRect">
+            <a:avLst>
+              <a:gd name="adj" fmla="val 6000"/>
+            </a:avLst>
+          </a:prstGeom>
+          <a:solidFill>
+            <a:srgbClr val="1E222C"/>
+          </a:solidFill>
+          <a:ln>
+            <a:noFill/>
+          </a:ln>
+          <a:effectLst/>
+        </p:spPr>
+        <p:txBody>
+          <a:bodyPr rtlCol="0" anchor="t" wrap="square" lIns="164592" rIns="164592" tIns="91440" bIns="91440"/>
+          <a:lstStyle/>
+          <a:p>
+            <a:pPr algn="l">
+              <a:lnSpc>
+                <a:spcPct val="100000"/>
+              </a:lnSpc>
+            </a:pPr>
+            <a:r>
+              <a:rPr sz="3400" b="1">
+                <a:solidFill>
+                  <a:srgbClr val="4FD1C5"/>
+                </a:solidFill>
+                <a:latin typeface="Arial"/>
+              </a:rPr>
+              <a:t>10</a:t>
+            </a:r>
+          </a:p>
+          <a:p>
+            <a:pPr algn="l">
+              <a:lnSpc>
+                <a:spcPct val="120000"/>
+              </a:lnSpc>
+            </a:pPr>
+            <a:r>
+              <a:rPr sz="1150" b="0">
+                <a:solidFill>
+                  <a:srgbClr val="9BA6B8"/>
+                </a:solidFill>
+                <a:latin typeface="Arial"/>
+              </a:rPr>
+              <a:t>Held-out generated tenancies, same scores; the generator exposed two defects the curated set missed</a:t>
+            </a:r>
+          </a:p>
+        </p:txBody>
+      </p:sp>
+      <p:sp>
+        <p:nvSpPr>
+          <p:cNvPr id="9" name="Rounded Rectangle 8"/>
+          <p:cNvSpPr/>
+          <p:nvPr/>
+        </p:nvSpPr>
+        <p:spPr>
+          <a:xfrm>
+            <a:off x="8028431" y="1920240"/>
+            <a:ext cx="3246120" cy="1874519"/>
+          </a:xfrm>
+          <a:prstGeom prst="roundRect">
+            <a:avLst>
+              <a:gd name="adj" fmla="val 6000"/>
+            </a:avLst>
+          </a:prstGeom>
+          <a:solidFill>
+            <a:srgbClr val="1E222C"/>
+          </a:solidFill>
+          <a:ln>
+            <a:noFill/>
+          </a:ln>
+          <a:effectLst/>
+        </p:spPr>
+        <p:txBody>
+          <a:bodyPr rtlCol="0" anchor="t" wrap="square" lIns="164592" rIns="164592" tIns="91440" bIns="91440"/>
+          <a:lstStyle/>
+          <a:p>
+            <a:pPr algn="l">
+              <a:lnSpc>
+                <a:spcPct val="100000"/>
+              </a:lnSpc>
+            </a:pPr>
+            <a:r>
+              <a:rPr sz="3400" b="1">
+                <a:solidFill>
+                  <a:srgbClr val="F2B36B"/>
+                </a:solidFill>
+                <a:latin typeface="Arial"/>
+              </a:rPr>
+              <a:t>465</a:t>
+            </a:r>
+          </a:p>
+          <a:p>
+            <a:pPr algn="l">
+              <a:lnSpc>
+                <a:spcPct val="120000"/>
+              </a:lnSpc>
+            </a:pPr>
+            <a:r>
+              <a:rPr sz="1150" b="0">
+                <a:solidFill>
+                  <a:srgbClr val="9BA6B8"/>
+                </a:solidFill>
+                <a:latin typeface="Arial"/>
+              </a:rPr>
+              <a:t>Tests, including sample-mode isolation enforced by blocking sockets and subprocess creation</a:t>
+            </a:r>
+          </a:p>
+        </p:txBody>
+      </p:sp>
+      <p:sp>
+        <p:nvSpPr>
+          <p:cNvPr id="10" name="TextBox 9"/>
           <p:cNvSpPr txBox="1"/>
           <p:nvPr/>
         </p:nvSpPr>
         <p:spPr>
           <a:xfrm>
-            <a:off x="914400" y="1874519"/>
-            <a:ext cx="10362895" cy="4114800"/>
+            <a:off x="914400" y="4069080"/>
+            <a:ext cx="10362895" cy="1920239"/>
           </a:xfrm>
           <a:prstGeom prst="rect">
             <a:avLst/>
@@ -4756,19 +5010,19 @@
                 <a:spcPct val="122000"/>
               </a:lnSpc>
               <a:spcAft>
-                <a:spcPts val="1300"/>
+                <a:spcPts val="800"/>
               </a:spcAft>
               <a:buFont typeface="Arial"/>
               <a:buChar char="—"/>
             </a:pPr>
             <a:r>
-              <a:rPr sz="1700" b="0">
+              <a:rPr sz="1450" b="0">
                 <a:solidFill>
                   <a:srgbClr val="EDEFF4"/>
                 </a:solidFill>
                 <a:latin typeface="Arial"/>
               </a:rPr>
-              <a:t>Cursor drove the first two tasks before its free-tier quota ran out; the blocker was posted and the sessions are retained.</a:t>
+              <a:t>Undefined metrics stay n/a rather than being scored as perfect; a clean tenancy must produce no findings at all.</a:t>
             </a:r>
           </a:p>
           <a:p>
@@ -4777,19 +5031,19 @@
                 <a:spcPct val="122000"/>
               </a:lnSpc>
               <a:spcAft>
-                <a:spcPts val="1300"/>
+                <a:spcPts val="800"/>
               </a:spcAft>
               <a:buFont typeface="Arial"/>
               <a:buChar char="—"/>
             </a:pPr>
             <a:r>
-              <a:rPr sz="1700" b="0">
+              <a:rPr sz="1450" b="0">
                 <a:solidFill>
                   <a:srgbClr val="EDEFF4"/>
                 </a:solidFill>
                 <a:latin typeface="Arial"/>
               </a:rPr>
-              <a:t>Hermes drove the remaining tasks with tests first; per-task attribution lives in the committed build log.</a:t>
+              <a:t>Every external call has a timeout, every loop has a cap, and a run finishes in minutes.</a:t>
             </a:r>
           </a:p>
           <a:p>
@@ -4798,40 +5052,19 @@
                 <a:spcPct val="122000"/>
               </a:lnSpc>
               <a:spcAft>
-                <a:spcPts val="1300"/>
+                <a:spcPts val="800"/>
               </a:spcAft>
               <a:buFont typeface="Arial"/>
               <a:buChar char="—"/>
             </a:pPr>
             <a:r>
-              <a:rPr sz="1700" b="0">
+              <a:rPr sz="1450" b="0">
                 <a:solidFill>
                   <a:srgbClr val="EDEFF4"/>
                 </a:solidFill>
                 <a:latin typeface="Arial"/>
               </a:rPr>
-              <a:t>Every mutating step on the live Zetaris instance went through a dry-run approval package first — recorded in decisions.md.</a:t>
-            </a:r>
-          </a:p>
-          <a:p>
-            <a:pPr algn="l" marL="274320" indent="-274320">
-              <a:lnSpc>
-                <a:spcPct val="122000"/>
-              </a:lnSpc>
-              <a:spcAft>
-                <a:spcPts val="1300"/>
-              </a:spcAft>
-              <a:buFont typeface="Arial"/>
-              <a:buChar char="—"/>
-            </a:pPr>
-            <a:r>
-              <a:rPr sz="1700" b="0">
-                <a:solidFill>
-                  <a:srgbClr val="EDEFF4"/>
-                </a:solidFill>
-                <a:latin typeface="Arial"/>
-              </a:rPr>
-              <a:t>Pre-existing components are declared in the submission form; the build window work is scored separately.</a:t>
+              <a:t>Packaging verified from a fresh public clone, and the offline path re-run with network and DNS denied.</a:t>
             </a:r>
           </a:p>
         </p:txBody>
@@ -4896,7 +5129,7 @@
                 </a:solidFill>
                 <a:latin typeface="Arial"/>
               </a:rPr>
-              <a:t>REPRODUCE</a:t>
+              <a:t>DISCLOSURE</a:t>
             </a:r>
           </a:p>
         </p:txBody>
@@ -4935,7 +5168,7 @@
                 </a:solidFill>
                 <a:latin typeface="Arial"/>
               </a:rPr>
-              <a:t>Run it yourself — no keys required</a:t>
+              <a:t>How it was built — attributed honestly</a:t>
             </a:r>
           </a:p>
         </p:txBody>
@@ -5049,6 +5282,330 @@
                 <a:latin typeface="Arial"/>
               </a:rPr>
               <a:t>11</a:t>
+            </a:r>
+          </a:p>
+        </p:txBody>
+      </p:sp>
+      <p:sp>
+        <p:nvSpPr>
+          <p:cNvPr id="7" name="TextBox 6"/>
+          <p:cNvSpPr txBox="1"/>
+          <p:nvPr/>
+        </p:nvSpPr>
+        <p:spPr>
+          <a:xfrm>
+            <a:off x="914400" y="1874519"/>
+            <a:ext cx="10362895" cy="4114800"/>
+          </a:xfrm>
+          <a:prstGeom prst="rect">
+            <a:avLst/>
+          </a:prstGeom>
+          <a:noFill/>
+        </p:spPr>
+        <p:txBody>
+          <a:bodyPr wrap="square" anchor="ctr" lIns="0" rIns="0" tIns="0" bIns="0">
+            <a:spAutoFit/>
+          </a:bodyPr>
+          <a:lstStyle/>
+          <a:p>
+            <a:pPr algn="l" marL="274320" indent="-274320">
+              <a:lnSpc>
+                <a:spcPct val="122000"/>
+              </a:lnSpc>
+              <a:spcAft>
+                <a:spcPts val="1300"/>
+              </a:spcAft>
+              <a:buFont typeface="Arial"/>
+              <a:buChar char="—"/>
+            </a:pPr>
+            <a:r>
+              <a:rPr sz="1700" b="0">
+                <a:solidFill>
+                  <a:srgbClr val="EDEFF4"/>
+                </a:solidFill>
+                <a:latin typeface="Arial"/>
+              </a:rPr>
+              <a:t>Cursor drove the first two tasks before its free-tier quota ran out; the blocker was posted and the sessions are retained.</a:t>
+            </a:r>
+          </a:p>
+          <a:p>
+            <a:pPr algn="l" marL="274320" indent="-274320">
+              <a:lnSpc>
+                <a:spcPct val="122000"/>
+              </a:lnSpc>
+              <a:spcAft>
+                <a:spcPts val="1300"/>
+              </a:spcAft>
+              <a:buFont typeface="Arial"/>
+              <a:buChar char="—"/>
+            </a:pPr>
+            <a:r>
+              <a:rPr sz="1700" b="0">
+                <a:solidFill>
+                  <a:srgbClr val="EDEFF4"/>
+                </a:solidFill>
+                <a:latin typeface="Arial"/>
+              </a:rPr>
+              <a:t>Hermes drove the remaining tasks with tests first; per-task attribution lives in the committed build log.</a:t>
+            </a:r>
+          </a:p>
+          <a:p>
+            <a:pPr algn="l" marL="274320" indent="-274320">
+              <a:lnSpc>
+                <a:spcPct val="122000"/>
+              </a:lnSpc>
+              <a:spcAft>
+                <a:spcPts val="1300"/>
+              </a:spcAft>
+              <a:buFont typeface="Arial"/>
+              <a:buChar char="—"/>
+            </a:pPr>
+            <a:r>
+              <a:rPr sz="1700" b="0">
+                <a:solidFill>
+                  <a:srgbClr val="EDEFF4"/>
+                </a:solidFill>
+                <a:latin typeface="Arial"/>
+              </a:rPr>
+              <a:t>Every mutating step on the live Zetaris instance went through a dry-run approval package first — recorded in decisions.md.</a:t>
+            </a:r>
+          </a:p>
+          <a:p>
+            <a:pPr algn="l" marL="274320" indent="-274320">
+              <a:lnSpc>
+                <a:spcPct val="122000"/>
+              </a:lnSpc>
+              <a:spcAft>
+                <a:spcPts val="1300"/>
+              </a:spcAft>
+              <a:buFont typeface="Arial"/>
+              <a:buChar char="—"/>
+            </a:pPr>
+            <a:r>
+              <a:rPr sz="1700" b="0">
+                <a:solidFill>
+                  <a:srgbClr val="EDEFF4"/>
+                </a:solidFill>
+                <a:latin typeface="Arial"/>
+              </a:rPr>
+              <a:t>Pre-existing components are declared in the submission form; the build window work is scored separately.</a:t>
+            </a:r>
+          </a:p>
+        </p:txBody>
+      </p:sp>
+    </p:spTree>
+  </p:cSld>
+  <p:clrMapOvr>
+    <a:masterClrMapping/>
+  </p:clrMapOvr>
+</p:sld>
+</file>
+
+<file path=ppt/slides/slide12.xml><?xml version="1.0" encoding="utf-8"?>
+<p:sld xmlns:a="http://schemas.openxmlformats.org/drawingml/2006/main" xmlns:p="http://schemas.openxmlformats.org/presentationml/2006/main" xmlns:r="http://schemas.openxmlformats.org/officeDocument/2006/relationships">
+  <p:cSld>
+    <p:bg>
+      <p:bgPr>
+        <a:solidFill>
+          <a:srgbClr val="14161C"/>
+        </a:solidFill>
+        <a:effectLst/>
+      </p:bgPr>
+    </p:bg>
+    <p:spTree>
+      <p:nvGrpSpPr>
+        <p:cNvPr id="1" name=""/>
+        <p:cNvGrpSpPr/>
+        <p:nvPr/>
+      </p:nvGrpSpPr>
+      <p:grpSpPr/>
+      <p:sp>
+        <p:nvSpPr>
+          <p:cNvPr id="2" name="TextBox 1"/>
+          <p:cNvSpPr txBox="1"/>
+          <p:nvPr/>
+        </p:nvSpPr>
+        <p:spPr>
+          <a:xfrm>
+            <a:off x="914400" y="420624"/>
+            <a:ext cx="10362895" cy="274320"/>
+          </a:xfrm>
+          <a:prstGeom prst="rect">
+            <a:avLst/>
+          </a:prstGeom>
+          <a:noFill/>
+        </p:spPr>
+        <p:txBody>
+          <a:bodyPr wrap="square" anchor="t" lIns="0" rIns="0" tIns="0" bIns="0">
+            <a:spAutoFit/>
+          </a:bodyPr>
+          <a:lstStyle/>
+          <a:p>
+            <a:pPr algn="l">
+              <a:lnSpc>
+                <a:spcPct val="118000"/>
+              </a:lnSpc>
+            </a:pPr>
+            <a:r>
+              <a:rPr sz="1050" b="1">
+                <a:solidFill>
+                  <a:srgbClr val="4FD1C5"/>
+                </a:solidFill>
+                <a:latin typeface="Arial"/>
+              </a:rPr>
+              <a:t>REPRODUCE</a:t>
+            </a:r>
+          </a:p>
+        </p:txBody>
+      </p:sp>
+      <p:sp>
+        <p:nvSpPr>
+          <p:cNvPr id="3" name="TextBox 2"/>
+          <p:cNvSpPr txBox="1"/>
+          <p:nvPr/>
+        </p:nvSpPr>
+        <p:spPr>
+          <a:xfrm>
+            <a:off x="914400" y="713232"/>
+            <a:ext cx="10362895" cy="914400"/>
+          </a:xfrm>
+          <a:prstGeom prst="rect">
+            <a:avLst/>
+          </a:prstGeom>
+          <a:noFill/>
+        </p:spPr>
+        <p:txBody>
+          <a:bodyPr wrap="square" anchor="t" lIns="0" rIns="0" tIns="0" bIns="0">
+            <a:spAutoFit/>
+          </a:bodyPr>
+          <a:lstStyle/>
+          <a:p>
+            <a:pPr algn="l">
+              <a:lnSpc>
+                <a:spcPct val="105000"/>
+              </a:lnSpc>
+            </a:pPr>
+            <a:r>
+              <a:rPr sz="2900" b="1">
+                <a:solidFill>
+                  <a:srgbClr val="EDEFF4"/>
+                </a:solidFill>
+                <a:latin typeface="Arial"/>
+              </a:rPr>
+              <a:t>Run it yourself — no keys required</a:t>
+            </a:r>
+          </a:p>
+        </p:txBody>
+      </p:sp>
+      <p:cxnSp>
+        <p:nvCxnSpPr>
+          <p:cNvPr id="4" name="Connector 3"/>
+          <p:cNvCxnSpPr/>
+          <p:nvPr/>
+        </p:nvCxnSpPr>
+        <p:spPr>
+          <a:xfrm>
+            <a:off x="914400" y="1627632"/>
+            <a:ext cx="1371600" cy="0"/>
+          </a:xfrm>
+          <a:prstGeom prst="line">
+            <a:avLst/>
+          </a:prstGeom>
+          <a:ln w="31750">
+            <a:solidFill>
+              <a:srgbClr val="4FD1C5"/>
+            </a:solidFill>
+          </a:ln>
+        </p:spPr>
+        <p:style>
+          <a:lnRef idx="2">
+            <a:schemeClr val="accent1"/>
+          </a:lnRef>
+          <a:fillRef idx="0">
+            <a:schemeClr val="accent1"/>
+          </a:fillRef>
+          <a:effectRef idx="1">
+            <a:schemeClr val="accent1"/>
+          </a:effectRef>
+          <a:fontRef idx="minor">
+            <a:schemeClr val="tx1"/>
+          </a:fontRef>
+        </p:style>
+      </p:cxnSp>
+      <p:sp>
+        <p:nvSpPr>
+          <p:cNvPr id="5" name="TextBox 4"/>
+          <p:cNvSpPr txBox="1"/>
+          <p:nvPr/>
+        </p:nvSpPr>
+        <p:spPr>
+          <a:xfrm>
+            <a:off x="914400" y="6291072"/>
+            <a:ext cx="7315200" cy="256032"/>
+          </a:xfrm>
+          <a:prstGeom prst="rect">
+            <a:avLst/>
+          </a:prstGeom>
+          <a:noFill/>
+        </p:spPr>
+        <p:txBody>
+          <a:bodyPr wrap="square" anchor="t" lIns="0" rIns="0" tIns="0" bIns="0">
+            <a:spAutoFit/>
+          </a:bodyPr>
+          <a:lstStyle/>
+          <a:p>
+            <a:pPr algn="l">
+              <a:lnSpc>
+                <a:spcPct val="118000"/>
+              </a:lnSpc>
+            </a:pPr>
+            <a:r>
+              <a:rPr sz="900" b="0">
+                <a:solidFill>
+                  <a:srgbClr val="9BA6B8"/>
+                </a:solidFill>
+                <a:latin typeface="Arial"/>
+              </a:rPr>
+              <a:t>Driftwatch  ·  Open Agent Hackathon 2026  ·  Wildcard [Tinkerer]</a:t>
+            </a:r>
+          </a:p>
+        </p:txBody>
+      </p:sp>
+      <p:sp>
+        <p:nvSpPr>
+          <p:cNvPr id="6" name="TextBox 5"/>
+          <p:cNvSpPr txBox="1"/>
+          <p:nvPr/>
+        </p:nvSpPr>
+        <p:spPr>
+          <a:xfrm>
+            <a:off x="10728655" y="6291072"/>
+            <a:ext cx="548640" cy="256032"/>
+          </a:xfrm>
+          <a:prstGeom prst="rect">
+            <a:avLst/>
+          </a:prstGeom>
+          <a:noFill/>
+        </p:spPr>
+        <p:txBody>
+          <a:bodyPr wrap="square" anchor="t" lIns="0" rIns="0" tIns="0" bIns="0">
+            <a:spAutoFit/>
+          </a:bodyPr>
+          <a:lstStyle/>
+          <a:p>
+            <a:pPr algn="r">
+              <a:lnSpc>
+                <a:spcPct val="118000"/>
+              </a:lnSpc>
+            </a:pPr>
+            <a:r>
+              <a:rPr sz="900" b="0">
+                <a:solidFill>
+                  <a:srgbClr val="9BA6B8"/>
+                </a:solidFill>
+                <a:latin typeface="Arial"/>
+              </a:rPr>
+              <a:t>12</a:t>
             </a:r>
           </a:p>
         </p:txBody>
@@ -8504,7 +9061,7 @@
                 </a:solidFill>
                 <a:latin typeface="Arial"/>
               </a:rPr>
-              <a:t>WHAT WENT WRONG</a:t>
+              <a:t>EVIDENCE · ZETARIS ACCEPTANCE</a:t>
             </a:r>
           </a:p>
         </p:txBody>
@@ -8543,7 +9100,7 @@
                 </a:solidFill>
                 <a:latin typeface="Arial"/>
               </a:rPr>
-              <a:t>Our guard caught a supplier bug in production</a:t>
+              <a:t>The acceptance run, as it printed</a:t>
             </a:r>
           </a:p>
         </p:txBody>
@@ -8670,7 +9227,7 @@
         <p:spPr>
           <a:xfrm>
             <a:off x="914400" y="1874519"/>
-            <a:ext cx="10362895" cy="4114800"/>
+            <a:ext cx="4160520" cy="4114800"/>
           </a:xfrm>
           <a:prstGeom prst="rect">
             <a:avLst/>
@@ -8688,19 +9245,19 @@
                 <a:spcPct val="122000"/>
               </a:lnSpc>
               <a:spcAft>
-                <a:spcPts val="1300"/>
+                <a:spcPts val="1200"/>
               </a:spcAft>
               <a:buFont typeface="Arial"/>
               <a:buChar char="—"/>
             </a:pPr>
             <a:r>
-              <a:rPr sz="1700" b="0">
+              <a:rPr sz="1450" b="0">
                 <a:solidFill>
                   <a:srgbClr val="EDEFF4"/>
                 </a:solidFill>
                 <a:latin typeface="Arial"/>
               </a:rPr>
-              <a:t>The live engine’s CSV parser silently truncated cells at embedded quotes — row counts and headers still looked perfect.</a:t>
+              <a:t>One command re-publishes the policy without rule R-1 and diffs the resulting findings against the base snapshot.</a:t>
             </a:r>
           </a:p>
           <a:p>
@@ -8709,19 +9266,19 @@
                 <a:spcPct val="122000"/>
               </a:lnSpc>
               <a:spcAft>
-                <a:spcPts val="1300"/>
+                <a:spcPts val="1200"/>
               </a:spcAft>
               <a:buFont typeface="Arial"/>
               <a:buChar char="—"/>
             </a:pPr>
             <a:r>
-              <a:rPr sz="1700" b="0">
+              <a:rPr sz="1450" b="0">
                 <a:solidFill>
                   <a:srgbClr val="EDEFF4"/>
                 </a:solidFill>
                 <a:latin typeface="Arial"/>
               </a:rPr>
-              <a:t>Our content-digest check rejected every affected fetch, so the run degraded to fixture data honestly instead of feeding corrupted rules to an agent.</a:t>
+              <a:t>only_in_base carries exactly one entry — the detached-volume finding R-1 produced; only_in_variant is empty.</a:t>
             </a:r>
           </a:p>
           <a:p>
@@ -8730,19 +9287,19 @@
                 <a:spcPct val="122000"/>
               </a:lnSpc>
               <a:spcAft>
-                <a:spcPts val="1300"/>
+                <a:spcPts val="1200"/>
               </a:spcAft>
               <a:buFont typeface="Arial"/>
               <a:buChar char="—"/>
             </a:pPr>
             <a:r>
-              <a:rPr sz="1700" b="0">
+              <a:rPr sz="1450" b="0">
                 <a:solidFill>
                   <a:srgbClr val="EDEFF4"/>
                 </a:solidFill>
                 <a:latin typeface="Arial"/>
               </a:rPr>
-              <a:t>Response: a quote-safe re-export with unchanged digests, new immutable snapshots, and v1 revoked and dropped.</a:t>
+              <a:t>The tool reports its own verdict: effect_observed true, sponsor_acceptance true.</a:t>
             </a:r>
           </a:p>
           <a:p>
@@ -8751,23 +9308,48 @@
                 <a:spcPct val="122000"/>
               </a:lnSpc>
               <a:spcAft>
-                <a:spcPts val="1300"/>
+                <a:spcPts val="1200"/>
               </a:spcAft>
               <a:buFont typeface="Arial"/>
               <a:buChar char="—"/>
             </a:pPr>
             <a:r>
-              <a:rPr sz="1700" b="0">
+              <a:rPr sz="1450" b="0">
                 <a:solidFill>
                   <a:srgbClr val="EDEFF4"/>
                 </a:solidFill>
                 <a:latin typeface="Arial"/>
               </a:rPr>
-              <a:t>“A connector’s happy path is not its contract — validate the payload after the wire, not just the status code.”</a:t>
-            </a:r>
-          </a:p>
-        </p:txBody>
-      </p:sp>
+              <a:t>This is the program's output, not a rendering of it.</a:t>
+            </a:r>
+          </a:p>
+        </p:txBody>
+      </p:sp>
+      <p:pic>
+        <p:nvPicPr>
+          <p:cNvPr id="8" name="Picture 7" descr="hero-frame.png"/>
+          <p:cNvPicPr>
+            <a:picLocks noChangeAspect="1"/>
+          </p:cNvPicPr>
+          <p:nvPr/>
+        </p:nvPicPr>
+        <p:blipFill>
+          <a:blip r:embed="rId2"/>
+          <a:srcRect l="382" r="382" t="536" b="536"/>
+          <a:stretch>
+            <a:fillRect/>
+          </a:stretch>
+        </p:blipFill>
+        <p:spPr>
+          <a:xfrm>
+            <a:off x="5349240" y="1874519"/>
+            <a:ext cx="5897880" cy="4202052"/>
+          </a:xfrm>
+          <a:prstGeom prst="rect">
+            <a:avLst/>
+          </a:prstGeom>
+        </p:spPr>
+      </p:pic>
     </p:spTree>
   </p:cSld>
   <p:clrMapOvr>
@@ -8828,7 +9410,7 @@
                 </a:solidFill>
                 <a:latin typeface="Arial"/>
               </a:rPr>
-              <a:t>MEASUREMENT</a:t>
+              <a:t>WHAT WENT WRONG</a:t>
             </a:r>
           </a:p>
         </p:txBody>
@@ -8867,7 +9449,7 @@
                 </a:solidFill>
                 <a:latin typeface="Arial"/>
               </a:rPr>
-              <a:t>Measured, not promised</a:t>
+              <a:t>Our guard caught a supplier bug in production</a:t>
             </a:r>
           </a:p>
         </p:txBody>
@@ -8987,197 +9569,14 @@
       </p:sp>
       <p:sp>
         <p:nvSpPr>
-          <p:cNvPr id="7" name="Rounded Rectangle 6"/>
-          <p:cNvSpPr/>
-          <p:nvPr/>
-        </p:nvSpPr>
-        <p:spPr>
-          <a:xfrm>
-            <a:off x="914400" y="1920240"/>
-            <a:ext cx="3246120" cy="1874519"/>
-          </a:xfrm>
-          <a:prstGeom prst="roundRect">
-            <a:avLst>
-              <a:gd name="adj" fmla="val 6000"/>
-            </a:avLst>
-          </a:prstGeom>
-          <a:solidFill>
-            <a:srgbClr val="1E222C"/>
-          </a:solidFill>
-          <a:ln>
-            <a:noFill/>
-          </a:ln>
-          <a:effectLst/>
-        </p:spPr>
-        <p:txBody>
-          <a:bodyPr rtlCol="0" anchor="t" wrap="square" lIns="164592" rIns="164592" tIns="91440" bIns="91440"/>
-          <a:lstStyle/>
-          <a:p>
-            <a:pPr algn="l">
-              <a:lnSpc>
-                <a:spcPct val="100000"/>
-              </a:lnSpc>
-            </a:pPr>
-            <a:r>
-              <a:rPr sz="3400" b="1">
-                <a:solidFill>
-                  <a:srgbClr val="4FD1C5"/>
-                </a:solidFill>
-                <a:latin typeface="Arial"/>
-              </a:rPr>
-              <a:t>3 / 3</a:t>
-            </a:r>
-          </a:p>
-          <a:p>
-            <a:pPr algn="l">
-              <a:lnSpc>
-                <a:spcPct val="120000"/>
-              </a:lnSpc>
-            </a:pPr>
-            <a:r>
-              <a:rPr sz="1150" b="0">
-                <a:solidFill>
-                  <a:srgbClr val="9BA6B8"/>
-                </a:solidFill>
-                <a:latin typeface="Arial"/>
-              </a:rPr>
-              <a:t>Curated scenarios — precision, recall and verdict accuracy all 1.0, deterministic</a:t>
-            </a:r>
-          </a:p>
-        </p:txBody>
-      </p:sp>
-      <p:sp>
-        <p:nvSpPr>
-          <p:cNvPr id="8" name="Rounded Rectangle 7"/>
-          <p:cNvSpPr/>
-          <p:nvPr/>
-        </p:nvSpPr>
-        <p:spPr>
-          <a:xfrm>
-            <a:off x="4471416" y="1920240"/>
-            <a:ext cx="3246120" cy="1874519"/>
-          </a:xfrm>
-          <a:prstGeom prst="roundRect">
-            <a:avLst>
-              <a:gd name="adj" fmla="val 6000"/>
-            </a:avLst>
-          </a:prstGeom>
-          <a:solidFill>
-            <a:srgbClr val="1E222C"/>
-          </a:solidFill>
-          <a:ln>
-            <a:noFill/>
-          </a:ln>
-          <a:effectLst/>
-        </p:spPr>
-        <p:txBody>
-          <a:bodyPr rtlCol="0" anchor="t" wrap="square" lIns="164592" rIns="164592" tIns="91440" bIns="91440"/>
-          <a:lstStyle/>
-          <a:p>
-            <a:pPr algn="l">
-              <a:lnSpc>
-                <a:spcPct val="100000"/>
-              </a:lnSpc>
-            </a:pPr>
-            <a:r>
-              <a:rPr sz="3400" b="1">
-                <a:solidFill>
-                  <a:srgbClr val="4FD1C5"/>
-                </a:solidFill>
-                <a:latin typeface="Arial"/>
-              </a:rPr>
-              <a:t>10</a:t>
-            </a:r>
-          </a:p>
-          <a:p>
-            <a:pPr algn="l">
-              <a:lnSpc>
-                <a:spcPct val="120000"/>
-              </a:lnSpc>
-            </a:pPr>
-            <a:r>
-              <a:rPr sz="1150" b="0">
-                <a:solidFill>
-                  <a:srgbClr val="9BA6B8"/>
-                </a:solidFill>
-                <a:latin typeface="Arial"/>
-              </a:rPr>
-              <a:t>Held-out generated tenancies, same scores; the generator exposed two defects the curated set missed</a:t>
-            </a:r>
-          </a:p>
-        </p:txBody>
-      </p:sp>
-      <p:sp>
-        <p:nvSpPr>
-          <p:cNvPr id="9" name="Rounded Rectangle 8"/>
-          <p:cNvSpPr/>
-          <p:nvPr/>
-        </p:nvSpPr>
-        <p:spPr>
-          <a:xfrm>
-            <a:off x="8028431" y="1920240"/>
-            <a:ext cx="3246120" cy="1874519"/>
-          </a:xfrm>
-          <a:prstGeom prst="roundRect">
-            <a:avLst>
-              <a:gd name="adj" fmla="val 6000"/>
-            </a:avLst>
-          </a:prstGeom>
-          <a:solidFill>
-            <a:srgbClr val="1E222C"/>
-          </a:solidFill>
-          <a:ln>
-            <a:noFill/>
-          </a:ln>
-          <a:effectLst/>
-        </p:spPr>
-        <p:txBody>
-          <a:bodyPr rtlCol="0" anchor="t" wrap="square" lIns="164592" rIns="164592" tIns="91440" bIns="91440"/>
-          <a:lstStyle/>
-          <a:p>
-            <a:pPr algn="l">
-              <a:lnSpc>
-                <a:spcPct val="100000"/>
-              </a:lnSpc>
-            </a:pPr>
-            <a:r>
-              <a:rPr sz="3400" b="1">
-                <a:solidFill>
-                  <a:srgbClr val="F2B36B"/>
-                </a:solidFill>
-                <a:latin typeface="Arial"/>
-              </a:rPr>
-              <a:t>465</a:t>
-            </a:r>
-          </a:p>
-          <a:p>
-            <a:pPr algn="l">
-              <a:lnSpc>
-                <a:spcPct val="120000"/>
-              </a:lnSpc>
-            </a:pPr>
-            <a:r>
-              <a:rPr sz="1150" b="0">
-                <a:solidFill>
-                  <a:srgbClr val="9BA6B8"/>
-                </a:solidFill>
-                <a:latin typeface="Arial"/>
-              </a:rPr>
-              <a:t>Tests, including sample-mode isolation enforced by blocking sockets and subprocess creation</a:t>
-            </a:r>
-          </a:p>
-        </p:txBody>
-      </p:sp>
-      <p:sp>
-        <p:nvSpPr>
-          <p:cNvPr id="10" name="TextBox 9"/>
+          <p:cNvPr id="7" name="TextBox 6"/>
           <p:cNvSpPr txBox="1"/>
           <p:nvPr/>
         </p:nvSpPr>
         <p:spPr>
           <a:xfrm>
-            <a:off x="914400" y="4069080"/>
-            <a:ext cx="10362895" cy="1920239"/>
+            <a:off x="914400" y="1874519"/>
+            <a:ext cx="10362895" cy="4114800"/>
           </a:xfrm>
           <a:prstGeom prst="rect">
             <a:avLst/>
@@ -9195,19 +9594,19 @@
                 <a:spcPct val="122000"/>
               </a:lnSpc>
               <a:spcAft>
-                <a:spcPts val="800"/>
+                <a:spcPts val="1300"/>
               </a:spcAft>
               <a:buFont typeface="Arial"/>
               <a:buChar char="—"/>
             </a:pPr>
             <a:r>
-              <a:rPr sz="1450" b="0">
+              <a:rPr sz="1700" b="0">
                 <a:solidFill>
                   <a:srgbClr val="EDEFF4"/>
                 </a:solidFill>
                 <a:latin typeface="Arial"/>
               </a:rPr>
-              <a:t>Undefined metrics stay n/a rather than being scored as perfect; a clean tenancy must produce no findings at all.</a:t>
+              <a:t>The live engine’s CSV parser silently truncated cells at embedded quotes — row counts and headers still looked perfect.</a:t>
             </a:r>
           </a:p>
           <a:p>
@@ -9216,19 +9615,19 @@
                 <a:spcPct val="122000"/>
               </a:lnSpc>
               <a:spcAft>
-                <a:spcPts val="800"/>
+                <a:spcPts val="1300"/>
               </a:spcAft>
               <a:buFont typeface="Arial"/>
               <a:buChar char="—"/>
             </a:pPr>
             <a:r>
-              <a:rPr sz="1450" b="0">
+              <a:rPr sz="1700" b="0">
                 <a:solidFill>
                   <a:srgbClr val="EDEFF4"/>
                 </a:solidFill>
                 <a:latin typeface="Arial"/>
               </a:rPr>
-              <a:t>Every external call has a timeout, every loop has a cap, and a run finishes in minutes.</a:t>
+              <a:t>Our content-digest check rejected every affected fetch, so the run degraded to fixture data honestly instead of feeding corrupted rules to an agent.</a:t>
             </a:r>
           </a:p>
           <a:p>
@@ -9237,19 +9636,40 @@
                 <a:spcPct val="122000"/>
               </a:lnSpc>
               <a:spcAft>
-                <a:spcPts val="800"/>
+                <a:spcPts val="1300"/>
               </a:spcAft>
               <a:buFont typeface="Arial"/>
               <a:buChar char="—"/>
             </a:pPr>
             <a:r>
-              <a:rPr sz="1450" b="0">
+              <a:rPr sz="1700" b="0">
                 <a:solidFill>
                   <a:srgbClr val="EDEFF4"/>
                 </a:solidFill>
                 <a:latin typeface="Arial"/>
               </a:rPr>
-              <a:t>Packaging verified from a fresh public clone, and the offline path re-run with network and DNS denied.</a:t>
+              <a:t>Response: a quote-safe re-export with unchanged digests, new immutable snapshots, and v1 revoked and dropped.</a:t>
+            </a:r>
+          </a:p>
+          <a:p>
+            <a:pPr algn="l" marL="274320" indent="-274320">
+              <a:lnSpc>
+                <a:spcPct val="122000"/>
+              </a:lnSpc>
+              <a:spcAft>
+                <a:spcPts val="1300"/>
+              </a:spcAft>
+              <a:buFont typeface="Arial"/>
+              <a:buChar char="—"/>
+            </a:pPr>
+            <a:r>
+              <a:rPr sz="1700" b="0">
+                <a:solidFill>
+                  <a:srgbClr val="EDEFF4"/>
+                </a:solidFill>
+                <a:latin typeface="Arial"/>
+              </a:rPr>
+              <a:t>“A connector’s happy path is not its contract — validate the payload after the wire, not just the status code.”</a:t>
             </a:r>
           </a:p>
         </p:txBody>

</xml_diff>